<commit_message>
Fix V80 slide title alignment to display on one line
Co-Authored-By: Claude Opus 4.6 (1M context) <noreply@anthropic.com>
</commit_message>
<xml_diff>
--- a/docs/V80/V80_Link.pptx
+++ b/docs/V80/V80_Link.pptx
@@ -5179,8 +5179,8 @@
         </p:nvSpPr>
         <p:spPr>
           <a:xfrm>
-            <a:off x="1597406" y="286270"/>
-            <a:ext cx="4119154" cy="369332"/>
+            <a:off x="457200" y="286270"/>
+            <a:ext cx="11274552" cy="369332"/>
           </a:xfrm>
           <a:prstGeom prst="rect">
             <a:avLst/>

</xml_diff>